<commit_message>
BPP manuscript: clarify hospital counts as facility counts and add risk-perception limitation
Co-Authored-By: Tatsuki Onishi <bougtoir@gmail.com>
</commit_message>
<xml_diff>
--- a/medical_accident_its_analysis/manuscript/bmj_figures_en.pptx
+++ b/medical_accident_its_analysis/manuscript/bmj_figures_en.pptx
@@ -342,7 +342,7 @@
           <a:p>
             <a:fld id="{C1FF6DA9-008F-8B48-92A6-B652298478BF}" type="slidenum">
               <a:rPr lang="en-US" smtClean="0"/>
-              <a:t>‹#›</a:t>
+              <a:t>#</a:t>
             </a:fld>
             <a:endParaRPr lang="en-US"/>
           </a:p>
@@ -512,7 +512,7 @@
           <a:p>
             <a:fld id="{C1FF6DA9-008F-8B48-92A6-B652298478BF}" type="slidenum">
               <a:rPr lang="en-US" smtClean="0"/>
-              <a:t>‹#›</a:t>
+              <a:t>#</a:t>
             </a:fld>
             <a:endParaRPr lang="en-US"/>
           </a:p>
@@ -692,7 +692,7 @@
           <a:p>
             <a:fld id="{C1FF6DA9-008F-8B48-92A6-B652298478BF}" type="slidenum">
               <a:rPr lang="en-US" smtClean="0"/>
-              <a:t>‹#›</a:t>
+              <a:t>#</a:t>
             </a:fld>
             <a:endParaRPr lang="en-US"/>
           </a:p>
@@ -862,7 +862,7 @@
           <a:p>
             <a:fld id="{C1FF6DA9-008F-8B48-92A6-B652298478BF}" type="slidenum">
               <a:rPr lang="en-US" smtClean="0"/>
-              <a:t>‹#›</a:t>
+              <a:t>#</a:t>
             </a:fld>
             <a:endParaRPr lang="en-US"/>
           </a:p>
@@ -1108,7 +1108,7 @@
           <a:p>
             <a:fld id="{C1FF6DA9-008F-8B48-92A6-B652298478BF}" type="slidenum">
               <a:rPr lang="en-US" smtClean="0"/>
-              <a:t>‹#›</a:t>
+              <a:t>#</a:t>
             </a:fld>
             <a:endParaRPr lang="en-US"/>
           </a:p>
@@ -1396,7 +1396,7 @@
           <a:p>
             <a:fld id="{C1FF6DA9-008F-8B48-92A6-B652298478BF}" type="slidenum">
               <a:rPr lang="en-US" smtClean="0"/>
-              <a:t>‹#›</a:t>
+              <a:t>#</a:t>
             </a:fld>
             <a:endParaRPr lang="en-US"/>
           </a:p>
@@ -1818,7 +1818,7 @@
           <a:p>
             <a:fld id="{C1FF6DA9-008F-8B48-92A6-B652298478BF}" type="slidenum">
               <a:rPr lang="en-US" smtClean="0"/>
-              <a:t>‹#›</a:t>
+              <a:t>#</a:t>
             </a:fld>
             <a:endParaRPr lang="en-US"/>
           </a:p>
@@ -1936,7 +1936,7 @@
           <a:p>
             <a:fld id="{C1FF6DA9-008F-8B48-92A6-B652298478BF}" type="slidenum">
               <a:rPr lang="en-US" smtClean="0"/>
-              <a:t>‹#›</a:t>
+              <a:t>#</a:t>
             </a:fld>
             <a:endParaRPr lang="en-US"/>
           </a:p>
@@ -2031,7 +2031,7 @@
           <a:p>
             <a:fld id="{C1FF6DA9-008F-8B48-92A6-B652298478BF}" type="slidenum">
               <a:rPr lang="en-US" smtClean="0"/>
-              <a:t>‹#›</a:t>
+              <a:t>#</a:t>
             </a:fld>
             <a:endParaRPr lang="en-US"/>
           </a:p>
@@ -2308,7 +2308,7 @@
           <a:p>
             <a:fld id="{C1FF6DA9-008F-8B48-92A6-B652298478BF}" type="slidenum">
               <a:rPr lang="en-US" smtClean="0"/>
-              <a:t>‹#›</a:t>
+              <a:t>#</a:t>
             </a:fld>
             <a:endParaRPr lang="en-US"/>
           </a:p>
@@ -2561,7 +2561,7 @@
           <a:p>
             <a:fld id="{C1FF6DA9-008F-8B48-92A6-B652298478BF}" type="slidenum">
               <a:rPr lang="en-US" smtClean="0"/>
-              <a:t>‹#›</a:t>
+              <a:t>#</a:t>
             </a:fld>
             <a:endParaRPr lang="en-US"/>
           </a:p>
@@ -2810,7 +2810,7 @@
           <a:p>
             <a:fld id="{C1FF6DA9-008F-8B48-92A6-B652298478BF}" type="slidenum">
               <a:rPr lang="en-US" smtClean="0"/>
-              <a:t>‹#›</a:t>
+              <a:t>#</a:t>
             </a:fld>
             <a:endParaRPr lang="en-US"/>
           </a:p>
@@ -2860,7 +2860,7 @@
           <a:spcPct val="20000"/>
         </a:spcBef>
         <a:buFont typeface="Arial"/>
-        <a:buChar char="•"/>
+        <a:buChar char="*"/>
         <a:defRPr sz="3200" kern="1200">
           <a:solidFill>
             <a:schemeClr val="tx1"/>
@@ -2875,7 +2875,7 @@
           <a:spcPct val="20000"/>
         </a:spcBef>
         <a:buFont typeface="Arial"/>
-        <a:buChar char="–"/>
+        <a:buChar char="-"/>
         <a:defRPr sz="2800" kern="1200">
           <a:solidFill>
             <a:schemeClr val="tx1"/>
@@ -2890,7 +2890,7 @@
           <a:spcPct val="20000"/>
         </a:spcBef>
         <a:buFont typeface="Arial"/>
-        <a:buChar char="•"/>
+        <a:buChar char="*"/>
         <a:defRPr sz="2400" kern="1200">
           <a:solidFill>
             <a:schemeClr val="tx1"/>
@@ -2905,7 +2905,7 @@
           <a:spcPct val="20000"/>
         </a:spcBef>
         <a:buFont typeface="Arial"/>
-        <a:buChar char="–"/>
+        <a:buChar char="-"/>
         <a:defRPr sz="2000" kern="1200">
           <a:solidFill>
             <a:schemeClr val="tx1"/>
@@ -2920,7 +2920,7 @@
           <a:spcPct val="20000"/>
         </a:spcBef>
         <a:buFont typeface="Arial"/>
-        <a:buChar char="»"/>
+        <a:buChar char="&gt;&gt;"/>
         <a:defRPr sz="2000" kern="1200">
           <a:solidFill>
             <a:schemeClr val="tx1"/>
@@ -2935,7 +2935,7 @@
           <a:spcPct val="20000"/>
         </a:spcBef>
         <a:buFont typeface="Arial"/>
-        <a:buChar char="•"/>
+        <a:buChar char="*"/>
         <a:defRPr sz="2000" kern="1200">
           <a:solidFill>
             <a:schemeClr val="tx1"/>
@@ -2950,7 +2950,7 @@
           <a:spcPct val="20000"/>
         </a:spcBef>
         <a:buFont typeface="Arial"/>
-        <a:buChar char="•"/>
+        <a:buChar char="*"/>
         <a:defRPr sz="2000" kern="1200">
           <a:solidFill>
             <a:schemeClr val="tx1"/>
@@ -2965,7 +2965,7 @@
           <a:spcPct val="20000"/>
         </a:spcBef>
         <a:buFont typeface="Arial"/>
-        <a:buChar char="•"/>
+        <a:buChar char="*"/>
         <a:defRPr sz="2000" kern="1200">
           <a:solidFill>
             <a:schemeClr val="tx1"/>
@@ -2980,7 +2980,7 @@
           <a:spcPct val="20000"/>
         </a:spcBef>
         <a:buFont typeface="Arial"/>
-        <a:buChar char="•"/>
+        <a:buChar char="*"/>
         <a:defRPr sz="2000" kern="1200">
           <a:solidFill>
             <a:schemeClr val="tx1"/>
@@ -3481,7 +3481,7 @@
                         </a:defRPr>
                       </a:pPr>
                       <a:r>
-                        <a:t>−0.946</a:t>
+                        <a:t>-0.946</a:t>
                       </a:r>
                     </a:p>
                   </a:txBody>
@@ -3599,7 +3599,7 @@
                         </a:defRPr>
                       </a:pPr>
                       <a:r>
-                        <a:t>−0.947</a:t>
+                        <a:t>-0.947</a:t>
                       </a:r>
                     </a:p>
                   </a:txBody>
@@ -3705,7 +3705,7 @@
                         </a:defRPr>
                       </a:pPr>
                       <a:r>
-                        <a:t>−0.945</a:t>
+                        <a:t>-0.945</a:t>
                       </a:r>
                     </a:p>
                   </a:txBody>
@@ -3799,7 +3799,7 @@
                         </a:defRPr>
                       </a:pPr>
                       <a:r>
-                        <a:t>−4</a:t>
+                        <a:t>-4</a:t>
                       </a:r>
                     </a:p>
                   </a:txBody>
@@ -3823,7 +3823,7 @@
                         </a:defRPr>
                       </a:pPr>
                       <a:r>
-                        <a:t>−0.959</a:t>
+                        <a:t>-0.959</a:t>
                       </a:r>
                     </a:p>
                   </a:txBody>
@@ -3929,7 +3929,7 @@
                         </a:defRPr>
                       </a:pPr>
                       <a:r>
-                        <a:t>−0.973</a:t>
+                        <a:t>-0.973</a:t>
                       </a:r>
                     </a:p>
                   </a:txBody>
@@ -4047,7 +4047,7 @@
                         </a:defRPr>
                       </a:pPr>
                       <a:r>
-                        <a:t>−0.988</a:t>
+                        <a:t>-0.988</a:t>
                       </a:r>
                     </a:p>
                   </a:txBody>
@@ -4153,7 +4153,7 @@
                         </a:defRPr>
                       </a:pPr>
                       <a:r>
-                        <a:t>−0.909</a:t>
+                        <a:t>-0.909</a:t>
                       </a:r>
                     </a:p>
                   </a:txBody>
@@ -4247,7 +4247,7 @@
                         </a:defRPr>
                       </a:pPr>
                       <a:r>
-                        <a:t>−3</a:t>
+                        <a:t>-3</a:t>
                       </a:r>
                     </a:p>
                   </a:txBody>
@@ -4271,7 +4271,7 @@
                         </a:defRPr>
                       </a:pPr>
                       <a:r>
-                        <a:t>−0.941</a:t>
+                        <a:t>-0.941</a:t>
                       </a:r>
                     </a:p>
                   </a:txBody>
@@ -4377,7 +4377,7 @@
                         </a:defRPr>
                       </a:pPr>
                       <a:r>
-                        <a:t>−0.981</a:t>
+                        <a:t>-0.981</a:t>
                       </a:r>
                     </a:p>
                   </a:txBody>
@@ -4495,7 +4495,7 @@
                         </a:defRPr>
                       </a:pPr>
                       <a:r>
-                        <a:t>−0.969</a:t>
+                        <a:t>-0.969</a:t>
                       </a:r>
                     </a:p>
                   </a:txBody>
@@ -4541,7 +4541,7 @@
               </a:defRPr>
             </a:pPr>
             <a:r>
-              <a:t>Cross-correlation of linearly detrended accident and outcome series at lags −8 to +8 years. Positive lag = accident change precedes outcome change.</a:t>
+              <a:t>Cross-correlation of linearly detrended accident and outcome series at lags -8 to +8 years. Positive lag = accident change precedes outcome change.</a:t>
             </a:r>
           </a:p>
         </p:txBody>
@@ -6080,7 +6080,7 @@
                         </a:defRPr>
                       </a:pPr>
                       <a:r>
-                        <a:t>−0.1</a:t>
+                        <a:t>-0.1</a:t>
                       </a:r>
                     </a:p>
                   </a:txBody>
@@ -6252,7 +6252,7 @@
               </a:defRPr>
             </a:pPr>
             <a:r>
-              <a:t>Table 4. Projected annual workforce changes by specialty (2025–2034)</a:t>
+              <a:t>Table 4. Projected annual workforce changes by specialty (2025-2034)</a:t>
             </a:r>
           </a:p>
         </p:txBody>
@@ -6414,7 +6414,7 @@
                         </a:defRPr>
                       </a:pPr>
                       <a:r>
-                        <a:t>−260</a:t>
+                        <a:t>-260</a:t>
                       </a:r>
                     </a:p>
                   </a:txBody>
@@ -6434,7 +6434,7 @@
                         </a:defRPr>
                       </a:pPr>
                       <a:r>
-                        <a:t>−350</a:t>
+                        <a:t>-350</a:t>
                       </a:r>
                     </a:p>
                   </a:txBody>
@@ -6524,7 +6524,7 @@
                         </a:defRPr>
                       </a:pPr>
                       <a:r>
-                        <a:t>−65</a:t>
+                        <a:t>-65</a:t>
                       </a:r>
                     </a:p>
                   </a:txBody>
@@ -6614,7 +6614,7 @@
                         </a:defRPr>
                       </a:pPr>
                       <a:r>
-                        <a:t>−256</a:t>
+                        <a:t>-256</a:t>
                       </a:r>
                     </a:p>
                   </a:txBody>
@@ -6704,7 +6704,7 @@
                         </a:defRPr>
                       </a:pPr>
                       <a:r>
-                        <a:t>−188</a:t>
+                        <a:t>-188</a:t>
                       </a:r>
                     </a:p>
                   </a:txBody>
@@ -6728,7 +6728,7 @@
                         </a:defRPr>
                       </a:pPr>
                       <a:r>
-                        <a:t>−5</a:t>
+                        <a:t>-5</a:t>
                       </a:r>
                     </a:p>
                   </a:txBody>
@@ -6794,7 +6794,7 @@
                         </a:defRPr>
                       </a:pPr>
                       <a:r>
-                        <a:t>−34</a:t>
+                        <a:t>-34</a:t>
                       </a:r>
                     </a:p>
                   </a:txBody>
@@ -6954,7 +6954,7 @@
                         </a:defRPr>
                       </a:pPr>
                       <a:r>
-                        <a:t>−16</a:t>
+                        <a:t>-16</a:t>
                       </a:r>
                     </a:p>
                   </a:txBody>
@@ -6974,7 +6974,7 @@
                         </a:defRPr>
                       </a:pPr>
                       <a:r>
-                        <a:t>−97</a:t>
+                        <a:t>-97</a:t>
                       </a:r>
                     </a:p>
                   </a:txBody>
@@ -6994,7 +6994,7 @@
                         </a:defRPr>
                       </a:pPr>
                       <a:r>
-                        <a:t>−5</a:t>
+                        <a:t>-5</a:t>
                       </a:r>
                     </a:p>
                   </a:txBody>
@@ -7330,7 +7330,7 @@
               </a:defRPr>
             </a:pPr>
             <a:r>
-              <a:t>Panel A: Mandatory reports to the Japan Medical Safety Research Organisation (JMSR, 2015–2025). Panel B: Medical litigation statistics from the Supreme Court of Japan (2004–2023). Top 5 specialties by incident count highlighted.</a:t>
+              <a:t>Panel A: Mandatory reports to the Japan Medical Safety Research Organisation (JMSR, 2015-2025). Panel B: Medical litigation statistics from the Supreme Court of Japan (2004-2023). Top 5 specialties by incident count highlighted.</a:t>
             </a:r>
           </a:p>
         </p:txBody>
@@ -7786,7 +7786,7 @@
               </a:defRPr>
             </a:pPr>
             <a:r>
-              <a:t>Rows: specialties. Columns: accident definition × outcome combinations. Darker colour indicates stronger inverse correlation. Positive lag values indicate accident changes precede outcome changes.</a:t>
+              <a:t>Rows: specialties. Columns: accident definition * outcome combinations. Darker colour indicates stronger inverse correlation. Positive lag values indicate accident changes precede outcome changes.</a:t>
             </a:r>
           </a:p>
         </p:txBody>
@@ -7840,7 +7840,7 @@
               </a:defRPr>
             </a:pPr>
             <a:r>
-              <a:t>Figure 6. Projected physician counts by specialty (2025–2034)</a:t>
+              <a:t>Figure 6. Projected physician counts by specialty (2025-2034)</a:t>
             </a:r>
           </a:p>
         </p:txBody>
@@ -7954,7 +7954,7 @@
               </a:defRPr>
             </a:pPr>
             <a:r>
-              <a:t>Figure 7. Projected facility counts by specialty (2025–2034)</a:t>
+              <a:t>Figure 7. Projected facility counts by specialty (2025-2034)</a:t>
             </a:r>
           </a:p>
         </p:txBody>
@@ -8068,7 +8068,7 @@
               </a:defRPr>
             </a:pPr>
             <a:r>
-              <a:t>Figure 8. Projected trainee registrations by specialty (2025–2034)</a:t>
+              <a:t>Figure 8. Projected trainee registrations by specialty (2025-2034)</a:t>
             </a:r>
           </a:p>
         </p:txBody>
@@ -8128,7 +8128,7 @@
               </a:defRPr>
             </a:pPr>
             <a:r>
-              <a:t>Linear trend extrapolation based on available data (2018–2025), with 95% prediction intervals.</a:t>
+              <a:t>Linear trend extrapolation based on available data (2018-2025), with 95% prediction intervals.</a:t>
             </a:r>
           </a:p>
         </p:txBody>
@@ -8187,10 +8187,10 @@
         <a:latin typeface="Calibri"/>
         <a:ea typeface=""/>
         <a:cs typeface=""/>
-        <a:font script="Jpan" typeface="ＭＳ Ｐゴシック"/>
-        <a:font script="Hang" typeface="맑은 고딕"/>
-        <a:font script="Hans" typeface="宋体"/>
-        <a:font script="Hant" typeface="新細明體"/>
+        <a:font script="Jpan" typeface="MS PGothic"/>
+        <a:font script="Hang" typeface="Malgun Gothic"/>
+        <a:font script="Hans" typeface="SimSun"/>
+        <a:font script="Hant" typeface="PMingLiU"/>
         <a:font script="Arab" typeface="Times New Roman"/>
         <a:font script="Hebr" typeface="Times New Roman"/>
         <a:font script="Thai" typeface="Angsana New"/>
@@ -8222,10 +8222,10 @@
         <a:latin typeface="Calibri"/>
         <a:ea typeface=""/>
         <a:cs typeface=""/>
-        <a:font script="Jpan" typeface="ＭＳ Ｐゴシック"/>
-        <a:font script="Hang" typeface="맑은 고딕"/>
-        <a:font script="Hans" typeface="宋体"/>
-        <a:font script="Hant" typeface="新細明體"/>
+        <a:font script="Jpan" typeface="MS PGothic"/>
+        <a:font script="Hang" typeface="Malgun Gothic"/>
+        <a:font script="Hans" typeface="SimSun"/>
+        <a:font script="Hant" typeface="PMingLiU"/>
         <a:font script="Arab" typeface="Arial"/>
         <a:font script="Hebr" typeface="Arial"/>
         <a:font script="Thai" typeface="Cordia New"/>

</xml_diff>